<commit_message>
docs: compare upstream FastVideo with 910B port
</commit_message>
<xml_diff>
--- a/docs/presentation/MiniMax-H3_DMD2_四步蒸馏与昇腾适配_实际代码适配终版.pptx
+++ b/docs/presentation/MiniMax-H3_DMD2_四步蒸馏与昇腾适配_实际代码适配终版.pptx
@@ -660,7 +660,7 @@
             <a:pPr/>
             <a:r>
               <a:rPr lang="zh-CN" dirty="0"/>
-              <a:t>这次代码适配可以归成四层。设备层把预处理、sequence parallel 预热和阶段计时里的 CUDA 硬编码改走 current_platform，并补齐 NPU 随机数初始化。算子和精度层固定 Dense TORCH_SDPA，同时统一 Qwen3-VL RMSNorm 的 BF16 参数类型，再把 uniform_parameter_dtype 写入导出配置并在推理时恢复。分布式内存层让 Student、Teacher、Critic 使用 FSDP CPU offload，权重先在 CPU 暂存并逐张量映射、分片，避免完整三十三B模型先进入单卡。最后，数据和产物层接通本地有声视频预处理、H3 双模态 DMD2、NPU 随机状态保存、独立 Student 导出和严格四步推理对比。</a:t>
+              <a:t>原版 FastVideo 已经提供了 NPUPlatform 和 HCCL communicator，但 H3 路径里仍然残留 CUDA 硬编码：阶段计时固定调用 CUDA 同步，预处理写死 cuda:0，sequence parallel 预热也默认 CUDA 设备；我们把这些位置统一改成 current_platform 和当前 rank 的本地 NPU。Dense FastH3 推理原来固定使用 FLASH_ATTN，我们开放 dense attention 后端选择，并在 910B 入口固定 TORCH_SDPA，避开 FlashAttention 和 Triton 的 CUDA kernel。三套三十三B角色还会在 FSDP 分片前形成很高的权重加载峰值，因此 NPU 路径改成先在 CPU 暂存，再逐张量映射和分片，同时对 Student、Teacher、Critic 开启 FSDP CPU offload。最后新增 Ascend 启动脚本和 910B 配置，负责 torch_npu 检查、NPU 发现、HCCL 与显存分配设置，并把 checkpoint 中写死的 CUDA 随机状态改成按照当前加速器保存和恢复。</a:t>
             </a:r>
           </a:p>
         </p:txBody>
@@ -8716,7 +8716,7 @@
           <p:spPr>
             <a:xfrm>
               <a:off x="495300" y="609600"/>
-              <a:ext cx="6762750" cy="590550"/>
+              <a:ext cx="7620000" cy="590550"/>
             </a:xfrm>
             <a:prstGeom prst="rect">
               <a:avLst/>
@@ -8736,7 +8736,7 @@
           <p:spPr>
             <a:xfrm>
               <a:off x="499110" y="628650"/>
-              <a:ext cx="6596666" cy="586740"/>
+              <a:ext cx="7424636" cy="586740"/>
             </a:xfrm>
             <a:prstGeom prst="rect">
               <a:avLst/>
@@ -8762,7 +8762,7 @@
                   <a:ea typeface="Microsoft YaHei"/>
                   <a:cs typeface="Arial"/>
                 </a:rPr>
-                <a:t>FastVideo 昇腾适配的实际代码改动</a:t>
+                <a:t>原版 FastVideo 到 910B：四个关键改动</a:t>
               </a:r>
             </a:p>
           </p:txBody>
@@ -8775,8 +8775,8 @@
           </p:nvSpPr>
           <p:spPr>
             <a:xfrm>
-              <a:off x="8382000" y="781050"/>
-              <a:ext cx="3276600" cy="247650"/>
+              <a:off x="7620000" y="781050"/>
+              <a:ext cx="4038600" cy="247650"/>
             </a:xfrm>
             <a:prstGeom prst="rect">
               <a:avLst/>
@@ -8795,8 +8795,8 @@
           </p:nvSpPr>
           <p:spPr>
             <a:xfrm>
-              <a:off x="8490966" y="820102"/>
-              <a:ext cx="2130933" cy="205359"/>
+              <a:off x="7728966" y="820102"/>
+              <a:ext cx="3292707" cy="205359"/>
             </a:xfrm>
             <a:prstGeom prst="rect">
               <a:avLst/>
@@ -8822,7 +8822,7 @@
                   <a:ea typeface="Microsoft YaHei"/>
                   <a:cs typeface="Arial"/>
                 </a:rPr>
-                <a:t>按当前补丁包的代码落点归为四层</a:t>
+                <a:t>上游已有 NPUPlatform / HCCL，本次补齐 H3 路径</a:t>
               </a:r>
             </a:p>
           </p:txBody>
@@ -8913,7 +8913,7 @@
           <p:spPr>
             <a:xfrm>
               <a:off x="3308985" y="1516856"/>
-              <a:ext cx="614528" cy="220028"/>
+              <a:ext cx="1589192" cy="220028"/>
             </a:xfrm>
             <a:prstGeom prst="rect">
               <a:avLst/>
@@ -8939,7 +8939,7 @@
                   <a:ea typeface="Microsoft YaHei"/>
                   <a:cs typeface="Arial"/>
                 </a:rPr>
-                <a:t>实际修改</a:t>
+                <a:t>原版 FastVideo 的断点</a:t>
               </a:r>
             </a:p>
           </p:txBody>
@@ -8953,7 +8953,7 @@
           <p:spPr>
             <a:xfrm>
               <a:off x="8242935" y="1516856"/>
-              <a:ext cx="765302" cy="220028"/>
+              <a:ext cx="1277361" cy="220028"/>
             </a:xfrm>
             <a:prstGeom prst="rect">
               <a:avLst/>
@@ -8979,7 +8979,7 @@
                   <a:ea typeface="Microsoft YaHei"/>
                   <a:cs typeface="Arial"/>
                 </a:rPr>
-                <a:t>解决的问题</a:t>
+                <a:t>针对 910B 的修改</a:t>
               </a:r>
             </a:p>
           </p:txBody>
@@ -9132,7 +9132,7 @@
           <p:spPr>
             <a:xfrm>
               <a:off x="1214438" y="2293620"/>
-              <a:ext cx="1851573" cy="176212"/>
+              <a:ext cx="1958338" cy="176212"/>
             </a:xfrm>
             <a:prstGeom prst="rect">
               <a:avLst/>
@@ -9158,7 +9158,7 @@
                   <a:ea typeface="Microsoft YaHei"/>
                   <a:cs typeface="Arial"/>
                 </a:rPr>
-                <a:t>消除运行路径中的 CUDA 硬编码</a:t>
+                <a:t>清除 H3 路径残留的 CUDA 硬编码</a:t>
               </a:r>
             </a:p>
           </p:txBody>
@@ -9172,7 +9172,7 @@
           <p:spPr>
             <a:xfrm>
               <a:off x="3308985" y="1955006"/>
-              <a:ext cx="3278802" cy="220028"/>
+              <a:ext cx="2750760" cy="220028"/>
             </a:xfrm>
             <a:prstGeom prst="rect">
               <a:avLst/>
@@ -9198,7 +9198,7 @@
                   <a:ea typeface="Microsoft YaHei"/>
                   <a:cs typeface="Arial"/>
                 </a:rPr>
-                <a:t>current_platform 接管 device、同步与缓存释放</a:t>
+                <a:t>阶段计时固定 torch.cuda.synchronize()</a:t>
               </a:r>
             </a:p>
           </p:txBody>
@@ -9212,7 +9212,7 @@
           <p:spPr>
             <a:xfrm>
               <a:off x="3309747" y="2218849"/>
-              <a:ext cx="2886702" cy="190690"/>
+              <a:ext cx="3136604" cy="190690"/>
             </a:xfrm>
             <a:prstGeom prst="rect">
               <a:avLst/>
@@ -9238,7 +9238,7 @@
                   <a:ea typeface="Microsoft YaHei"/>
                   <a:cs typeface="Arial"/>
                 </a:rPr>
-                <a:t>预处理、SP warm-up、阶段计时均改走当前设备</a:t>
+                <a:t>预处理写死 cuda:0；SP warm-up 默认 CUDA device</a:t>
               </a:r>
             </a:p>
           </p:txBody>
@@ -9252,7 +9252,7 @@
           <p:spPr>
             <a:xfrm>
               <a:off x="3309938" y="2446020"/>
-              <a:ext cx="3181635" cy="176212"/>
+              <a:ext cx="3706758" cy="176212"/>
             </a:xfrm>
             <a:prstGeom prst="rect">
               <a:avLst/>
@@ -9278,7 +9278,7 @@
                   <a:ea typeface="Arial"/>
                   <a:cs typeface="Arial"/>
                 </a:rPr>
-                <a:t>npu.py · base.py · communication_op.py · parallel_state.py</a:t>
+                <a:t>base.py · preprocess_minimax_h3_overfit.py · communication_op.py</a:t>
               </a:r>
             </a:p>
           </p:txBody>
@@ -9292,7 +9292,7 @@
           <p:spPr>
             <a:xfrm>
               <a:off x="8243316" y="1963102"/>
-              <a:ext cx="2045869" cy="205359"/>
+              <a:ext cx="2571341" cy="205359"/>
             </a:xfrm>
             <a:prstGeom prst="rect">
               <a:avLst/>
@@ -9318,7 +9318,7 @@
                   <a:ea typeface="Microsoft YaHei"/>
                   <a:cs typeface="Arial"/>
                 </a:rPr>
-                <a:t>八个 rank 各自使用正确的 NPU</a:t>
+                <a:t>全部改走 current_platform 与本地 NPU</a:t>
               </a:r>
             </a:p>
           </p:txBody>
@@ -9332,7 +9332,7 @@
           <p:spPr>
             <a:xfrm>
               <a:off x="8243697" y="2218849"/>
-              <a:ext cx="2689966" cy="190690"/>
+              <a:ext cx="3278859" cy="190690"/>
             </a:xfrm>
             <a:prstGeom prst="rect">
               <a:avLst/>
@@ -9358,7 +9358,7 @@
                   <a:ea typeface="Microsoft YaHei"/>
                   <a:cs typeface="Arial"/>
                 </a:rPr>
-                <a:t>torch.npu.synchronize() 替代固定 CUDA 同步</a:t>
+                <a:t>NPU 用 torch.npu.synchronize()，每个 rank 取本地设备</a:t>
               </a:r>
             </a:p>
           </p:txBody>
@@ -9372,7 +9372,7 @@
           <p:spPr>
             <a:xfrm>
               <a:off x="8243888" y="2446020"/>
-              <a:ext cx="2369225" cy="176212"/>
+              <a:ext cx="2457599" cy="176212"/>
             </a:xfrm>
             <a:prstGeom prst="rect">
               <a:avLst/>
@@ -9398,7 +9398,7 @@
                   <a:ea typeface="Microsoft YaHei"/>
                   <a:cs typeface="Arial"/>
                 </a:rPr>
-                <a:t>补齐 NPU seed_everything 与随机数初始化</a:t>
+                <a:t>缓存释放平台化；补齐 NPU seed_everything</a:t>
               </a:r>
             </a:p>
           </p:txBody>
@@ -9511,265 +9511,305 @@
           <p:spPr>
             <a:xfrm>
               <a:off x="1212342" y="2930842"/>
-              <a:ext cx="1094106" cy="264033"/>
-            </a:xfrm>
-            <a:prstGeom prst="rect">
-              <a:avLst/>
-            </a:prstGeom>
-            <a:noFill/>
-            <a:ln>
-              <a:noFill/>
-            </a:ln>
-          </p:spPr>
-          <p:txBody>
-            <a:bodyPr wrap="none" lIns="0" tIns="0" rIns="0" bIns="0" anchor="t" anchorCtr="0">
-              <a:spAutoFit/>
-            </a:bodyPr>
-            <a:lstStyle/>
-            <a:p>
-              <a:pPr algn="l"/>
-              <a:r>
-                <a:rPr lang="zh-CN" sz="1350" b="1" dirty="0">
+              <a:ext cx="1418361" cy="264033"/>
+            </a:xfrm>
+            <a:prstGeom prst="rect">
+              <a:avLst/>
+            </a:prstGeom>
+            <a:noFill/>
+            <a:ln>
+              <a:noFill/>
+            </a:ln>
+          </p:spPr>
+          <p:txBody>
+            <a:bodyPr wrap="none" lIns="0" tIns="0" rIns="0" bIns="0" anchor="t" anchorCtr="0">
+              <a:spAutoFit/>
+            </a:bodyPr>
+            <a:lstStyle/>
+            <a:p>
+              <a:pPr algn="l"/>
+              <a:r>
+                <a:rPr lang="en-US" sz="1350" b="1" dirty="0">
                   <a:solidFill>
                     <a:srgbClr val="2F6FA3"/>
+                  </a:solidFill>
+                  <a:latin typeface="Arial"/>
+                  <a:ea typeface="Arial"/>
+                  <a:cs typeface="Arial"/>
+                </a:rPr>
+                <a:t>Dense Attention</a:t>
+              </a:r>
+            </a:p>
+          </p:txBody>
+        </p:sp>
+        <p:sp>
+          <p:nvSpPr>
+            <p:cNvPr id="31" name="TextBox 31"/>
+            <p:cNvSpPr txBox="1"/>
+            <p:nvPr/>
+          </p:nvSpPr>
+          <p:spPr>
+            <a:xfrm>
+              <a:off x="1214438" y="3217545"/>
+              <a:ext cx="2211420" cy="176212"/>
+            </a:xfrm>
+            <a:prstGeom prst="rect">
+              <a:avLst/>
+            </a:prstGeom>
+            <a:noFill/>
+            <a:ln>
+              <a:noFill/>
+            </a:ln>
+          </p:spPr>
+          <p:txBody>
+            <a:bodyPr wrap="none" lIns="0" tIns="0" rIns="0" bIns="0" anchor="t" anchorCtr="0">
+              <a:spAutoFit/>
+            </a:bodyPr>
+            <a:lstStyle/>
+            <a:p>
+              <a:pPr algn="l"/>
+              <a:r>
+                <a:rPr lang="zh-CN" sz="900" dirty="0">
+                  <a:solidFill>
+                    <a:srgbClr val="626B73"/>
                   </a:solidFill>
                   <a:latin typeface="Arial"/>
                   <a:ea typeface="Microsoft YaHei"/>
                   <a:cs typeface="Arial"/>
                 </a:rPr>
-                <a:t>算子与 dtype</a:t>
-              </a:r>
-            </a:p>
-          </p:txBody>
-        </p:sp>
-        <p:sp>
-          <p:nvSpPr>
-            <p:cNvPr id="31" name="TextBox 31"/>
-            <p:cNvSpPr txBox="1"/>
-            <p:nvPr/>
-          </p:nvSpPr>
-          <p:spPr>
-            <a:xfrm>
-              <a:off x="1214438" y="3217545"/>
-              <a:ext cx="2185703" cy="176212"/>
-            </a:xfrm>
-            <a:prstGeom prst="rect">
-              <a:avLst/>
-            </a:prstGeom>
-            <a:noFill/>
-            <a:ln>
-              <a:noFill/>
-            </a:ln>
-          </p:spPr>
-          <p:txBody>
-            <a:bodyPr wrap="none" lIns="0" tIns="0" rIns="0" bIns="0" anchor="t" anchorCtr="0">
-              <a:spAutoFit/>
-            </a:bodyPr>
-            <a:lstStyle/>
-            <a:p>
-              <a:pPr algn="l"/>
-              <a:r>
-                <a:rPr lang="zh-CN" sz="900" dirty="0">
-                  <a:solidFill>
-                    <a:srgbClr val="626B73"/>
+                <a:t>移除 Dense 路径对 CUDA kernel 的依赖</a:t>
+              </a:r>
+            </a:p>
+          </p:txBody>
+        </p:sp>
+        <p:sp>
+          <p:nvSpPr>
+            <p:cNvPr id="32" name="TextBox 32"/>
+            <p:cNvSpPr txBox="1"/>
+            <p:nvPr/>
+          </p:nvSpPr>
+          <p:spPr>
+            <a:xfrm>
+              <a:off x="3308985" y="2878931"/>
+              <a:ext cx="3091744" cy="220028"/>
+            </a:xfrm>
+            <a:prstGeom prst="rect">
+              <a:avLst/>
+            </a:prstGeom>
+            <a:noFill/>
+            <a:ln>
+              <a:noFill/>
+            </a:ln>
+          </p:spPr>
+          <p:txBody>
+            <a:bodyPr wrap="none" lIns="0" tIns="0" rIns="0" bIns="0" anchor="t" anchorCtr="0">
+              <a:spAutoFit/>
+            </a:bodyPr>
+            <a:lstStyle/>
+            <a:p>
+              <a:pPr algn="l"/>
+              <a:r>
+                <a:rPr lang="zh-CN" sz="1120" b="1" dirty="0">
+                  <a:solidFill>
+                    <a:srgbClr val="20252B"/>
                   </a:solidFill>
                   <a:latin typeface="Arial"/>
                   <a:ea typeface="Microsoft YaHei"/>
                   <a:cs typeface="Arial"/>
                 </a:rPr>
-                <a:t>跑通 Dense BF16 前向与 FSDP 初始化</a:t>
-              </a:r>
-            </a:p>
-          </p:txBody>
-        </p:sp>
-        <p:sp>
-          <p:nvSpPr>
-            <p:cNvPr id="32" name="TextBox 32"/>
-            <p:cNvSpPr txBox="1"/>
-            <p:nvPr/>
-          </p:nvSpPr>
-          <p:spPr>
-            <a:xfrm>
-              <a:off x="3308985" y="2878931"/>
-              <a:ext cx="2748348" cy="220028"/>
-            </a:xfrm>
-            <a:prstGeom prst="rect">
-              <a:avLst/>
-            </a:prstGeom>
-            <a:noFill/>
-            <a:ln>
-              <a:noFill/>
-            </a:ln>
-          </p:spPr>
-          <p:txBody>
-            <a:bodyPr wrap="none" lIns="0" tIns="0" rIns="0" bIns="0" anchor="t" anchorCtr="0">
-              <a:spAutoFit/>
-            </a:bodyPr>
-            <a:lstStyle/>
-            <a:p>
-              <a:pPr algn="l"/>
-              <a:r>
-                <a:rPr lang="zh-CN" sz="1120" b="1" dirty="0">
-                  <a:solidFill>
-                    <a:srgbClr val="20252B"/>
+                <a:t>Dense FastH3 推理默认写死 FLASH_ATTN</a:t>
+              </a:r>
+            </a:p>
+          </p:txBody>
+        </p:sp>
+        <p:sp>
+          <p:nvSpPr>
+            <p:cNvPr id="33" name="TextBox 33"/>
+            <p:cNvSpPr txBox="1"/>
+            <p:nvPr/>
+          </p:nvSpPr>
+          <p:spPr>
+            <a:xfrm>
+              <a:off x="3309747" y="3142774"/>
+              <a:ext cx="3030182" cy="190690"/>
+            </a:xfrm>
+            <a:prstGeom prst="rect">
+              <a:avLst/>
+            </a:prstGeom>
+            <a:noFill/>
+            <a:ln>
+              <a:noFill/>
+            </a:ln>
+          </p:spPr>
+          <p:txBody>
+            <a:bodyPr wrap="none" lIns="0" tIns="0" rIns="0" bIns="0" anchor="t" anchorCtr="0">
+              <a:spAutoFit/>
+            </a:bodyPr>
+            <a:lstStyle/>
+            <a:p>
+              <a:pPr algn="l"/>
+              <a:r>
+                <a:rPr lang="zh-CN" sz="980" dirty="0">
+                  <a:solidFill>
+                    <a:srgbClr val="626B73"/>
                   </a:solidFill>
                   <a:latin typeface="Arial"/>
                   <a:ea typeface="Microsoft YaHei"/>
                   <a:cs typeface="Arial"/>
                 </a:rPr>
-                <a:t>训练与推理固定 Dense TORCH_SDPA</a:t>
-              </a:r>
-            </a:p>
-          </p:txBody>
-        </p:sp>
-        <p:sp>
-          <p:nvSpPr>
-            <p:cNvPr id="33" name="TextBox 33"/>
-            <p:cNvSpPr txBox="1"/>
-            <p:nvPr/>
-          </p:nvSpPr>
-          <p:spPr>
-            <a:xfrm>
-              <a:off x="3309747" y="3142774"/>
-              <a:ext cx="2723446" cy="190690"/>
-            </a:xfrm>
-            <a:prstGeom prst="rect">
-              <a:avLst/>
-            </a:prstGeom>
-            <a:noFill/>
-            <a:ln>
-              <a:noFill/>
-            </a:ln>
-          </p:spPr>
-          <p:txBody>
-            <a:bodyPr wrap="none" lIns="0" tIns="0" rIns="0" bIns="0" anchor="t" anchorCtr="0">
-              <a:spAutoFit/>
-            </a:bodyPr>
-            <a:lstStyle/>
-            <a:p>
-              <a:pPr algn="l"/>
-              <a:r>
-                <a:rPr lang="zh-CN" sz="980" dirty="0">
+                <a:t>训练插件和推理入口没有统一选择 NPU 可用后端</a:t>
+              </a:r>
+            </a:p>
+          </p:txBody>
+        </p:sp>
+        <p:sp>
+          <p:nvSpPr>
+            <p:cNvPr id="34" name="TextBox 34"/>
+            <p:cNvSpPr txBox="1"/>
+            <p:nvPr/>
+          </p:nvSpPr>
+          <p:spPr>
+            <a:xfrm>
+              <a:off x="3309938" y="3369945"/>
+              <a:ext cx="2565938" cy="176212"/>
+            </a:xfrm>
+            <a:prstGeom prst="rect">
+              <a:avLst/>
+            </a:prstGeom>
+            <a:noFill/>
+            <a:ln>
+              <a:noFill/>
+            </a:ln>
+          </p:spPr>
+          <p:txBody>
+            <a:bodyPr wrap="none" lIns="0" tIns="0" rIns="0" bIns="0" anchor="t" anchorCtr="0">
+              <a:spAutoFit/>
+            </a:bodyPr>
+            <a:lstStyle/>
+            <a:p>
+              <a:pPr algn="l"/>
+              <a:r>
+                <a:rPr lang="en-US" sz="900" dirty="0">
                   <a:solidFill>
                     <a:srgbClr val="626B73"/>
+                  </a:solidFill>
+                  <a:latin typeface="Arial"/>
+                  <a:ea typeface="Arial"/>
+                  <a:cs typeface="Arial"/>
+                </a:rPr>
+                <a:t>basic_fasth3.py · H3 training / inference configs</a:t>
+              </a:r>
+            </a:p>
+          </p:txBody>
+        </p:sp>
+        <p:sp>
+          <p:nvSpPr>
+            <p:cNvPr id="35" name="TextBox 35"/>
+            <p:cNvSpPr txBox="1"/>
+            <p:nvPr/>
+          </p:nvSpPr>
+          <p:spPr>
+            <a:xfrm>
+              <a:off x="8243316" y="2887028"/>
+              <a:ext cx="2911515" cy="205359"/>
+            </a:xfrm>
+            <a:prstGeom prst="rect">
+              <a:avLst/>
+            </a:prstGeom>
+            <a:noFill/>
+            <a:ln>
+              <a:noFill/>
+            </a:ln>
+          </p:spPr>
+          <p:txBody>
+            <a:bodyPr wrap="none" lIns="0" tIns="0" rIns="0" bIns="0" anchor="t" anchorCtr="0">
+              <a:spAutoFit/>
+            </a:bodyPr>
+            <a:lstStyle/>
+            <a:p>
+              <a:pPr algn="l"/>
+              <a:r>
+                <a:rPr lang="zh-CN" sz="1050" b="1" dirty="0">
+                  <a:solidFill>
+                    <a:srgbClr val="20252B"/>
                   </a:solidFill>
                   <a:latin typeface="Arial"/>
                   <a:ea typeface="Microsoft YaHei"/>
                   <a:cs typeface="Arial"/>
                 </a:rPr>
-                <a:t>Qwen3-VL RMSNorm 参数按默认 BF16 构造</a:t>
-              </a:r>
-            </a:p>
-          </p:txBody>
-        </p:sp>
-        <p:sp>
-          <p:nvSpPr>
-            <p:cNvPr id="34" name="TextBox 34"/>
-            <p:cNvSpPr txBox="1"/>
-            <p:nvPr/>
-          </p:nvSpPr>
-          <p:spPr>
-            <a:xfrm>
-              <a:off x="3309938" y="3369945"/>
-              <a:ext cx="2353278" cy="176212"/>
-            </a:xfrm>
-            <a:prstGeom prst="rect">
-              <a:avLst/>
-            </a:prstGeom>
-            <a:noFill/>
-            <a:ln>
-              <a:noFill/>
-            </a:ln>
-          </p:spPr>
-          <p:txBody>
-            <a:bodyPr wrap="none" lIns="0" tIns="0" rIns="0" bIns="0" anchor="t" anchorCtr="0">
-              <a:spAutoFit/>
-            </a:bodyPr>
-            <a:lstStyle/>
-            <a:p>
-              <a:pPr algn="l"/>
-              <a:r>
-                <a:rPr lang="en-US" sz="900" dirty="0">
+                <a:t>开放 Dense 后端选择并固定 TORCH_SDPA</a:t>
+              </a:r>
+            </a:p>
+          </p:txBody>
+        </p:sp>
+        <p:sp>
+          <p:nvSpPr>
+            <p:cNvPr id="36" name="TextBox 36"/>
+            <p:cNvSpPr txBox="1"/>
+            <p:nvPr/>
+          </p:nvSpPr>
+          <p:spPr>
+            <a:xfrm>
+              <a:off x="8243697" y="3142774"/>
+              <a:ext cx="3210653" cy="190690"/>
+            </a:xfrm>
+            <a:prstGeom prst="rect">
+              <a:avLst/>
+            </a:prstGeom>
+            <a:noFill/>
+            <a:ln>
+              <a:noFill/>
+            </a:ln>
+          </p:spPr>
+          <p:txBody>
+            <a:bodyPr wrap="none" lIns="0" tIns="0" rIns="0" bIns="0" anchor="t" anchorCtr="0">
+              <a:spAutoFit/>
+            </a:bodyPr>
+            <a:lstStyle/>
+            <a:p>
+              <a:pPr algn="l"/>
+              <a:r>
+                <a:rPr lang="zh-CN" sz="980" dirty="0">
                   <a:solidFill>
                     <a:srgbClr val="626B73"/>
-                  </a:solidFill>
-                  <a:latin typeface="Arial"/>
-                  <a:ea typeface="Arial"/>
-                  <a:cs typeface="Arial"/>
-                </a:rPr>
-                <a:t>minimax_h3_qwen3_vl.py · basic_fasth3.py</a:t>
-              </a:r>
-            </a:p>
-          </p:txBody>
-        </p:sp>
-        <p:sp>
-          <p:nvSpPr>
-            <p:cNvPr id="35" name="TextBox 35"/>
-            <p:cNvSpPr txBox="1"/>
-            <p:nvPr/>
-          </p:nvSpPr>
-          <p:spPr>
-            <a:xfrm>
-              <a:off x="8243316" y="2887028"/>
-              <a:ext cx="2538600" cy="205359"/>
-            </a:xfrm>
-            <a:prstGeom prst="rect">
-              <a:avLst/>
-            </a:prstGeom>
-            <a:noFill/>
-            <a:ln>
-              <a:noFill/>
-            </a:ln>
-          </p:spPr>
-          <p:txBody>
-            <a:bodyPr wrap="none" lIns="0" tIns="0" rIns="0" bIns="0" anchor="t" anchorCtr="0">
-              <a:spAutoFit/>
-            </a:bodyPr>
-            <a:lstStyle/>
-            <a:p>
-              <a:pPr algn="l"/>
-              <a:r>
-                <a:rPr lang="zh-CN" sz="1050" b="1" dirty="0">
-                  <a:solidFill>
-                    <a:srgbClr val="20252B"/>
                   </a:solidFill>
                   <a:latin typeface="Arial"/>
                   <a:ea typeface="Microsoft YaHei"/>
                   <a:cs typeface="Arial"/>
                 </a:rPr>
-                <a:t>同一 FSDP 参数组保持原始 dtype 一致</a:t>
-              </a:r>
-            </a:p>
-          </p:txBody>
-        </p:sp>
-        <p:sp>
-          <p:nvSpPr>
-            <p:cNvPr id="36" name="TextBox 36"/>
-            <p:cNvSpPr txBox="1"/>
-            <p:nvPr/>
-          </p:nvSpPr>
-          <p:spPr>
-            <a:xfrm>
-              <a:off x="8243697" y="3142774"/>
-              <a:ext cx="2406772" cy="190690"/>
-            </a:xfrm>
-            <a:prstGeom prst="rect">
-              <a:avLst/>
-            </a:prstGeom>
-            <a:noFill/>
-            <a:ln>
-              <a:noFill/>
-            </a:ln>
-          </p:spPr>
-          <p:txBody>
-            <a:bodyPr wrap="none" lIns="0" tIns="0" rIns="0" bIns="0" anchor="t" anchorCtr="0">
-              <a:spAutoFit/>
-            </a:bodyPr>
-            <a:lstStyle/>
-            <a:p>
-              <a:pPr algn="l"/>
-              <a:r>
-                <a:rPr lang="zh-CN" sz="980" dirty="0">
+                <a:t>训练、Base 对比和四步 Student 使用同一 Dense 实现</a:t>
+              </a:r>
+            </a:p>
+          </p:txBody>
+        </p:sp>
+        <p:sp>
+          <p:nvSpPr>
+            <p:cNvPr id="37" name="TextBox 37"/>
+            <p:cNvSpPr txBox="1"/>
+            <p:nvPr/>
+          </p:nvSpPr>
+          <p:spPr>
+            <a:xfrm>
+              <a:off x="8243888" y="3369945"/>
+              <a:ext cx="2485951" cy="176212"/>
+            </a:xfrm>
+            <a:prstGeom prst="rect">
+              <a:avLst/>
+            </a:prstGeom>
+            <a:noFill/>
+            <a:ln>
+              <a:noFill/>
+            </a:ln>
+          </p:spPr>
+          <p:txBody>
+            <a:bodyPr wrap="none" lIns="0" tIns="0" rIns="0" bIns="0" anchor="t" anchorCtr="0">
+              <a:spAutoFit/>
+            </a:bodyPr>
+            <a:lstStyle/>
+            <a:p>
+              <a:pPr algn="l"/>
+              <a:r>
+                <a:rPr lang="zh-CN" sz="900" dirty="0">
                   <a:solidFill>
                     <a:srgbClr val="626B73"/>
                   </a:solidFill>
@@ -9777,47 +9817,7 @@
                   <a:ea typeface="Microsoft YaHei"/>
                   <a:cs typeface="Arial"/>
                 </a:rPr>
-                <a:t>Norm 内部方差计算仍保留 FP32 稳定性</a:t>
-              </a:r>
-            </a:p>
-          </p:txBody>
-        </p:sp>
-        <p:sp>
-          <p:nvSpPr>
-            <p:cNvPr id="37" name="TextBox 37"/>
-            <p:cNvSpPr txBox="1"/>
-            <p:nvPr/>
-          </p:nvSpPr>
-          <p:spPr>
-            <a:xfrm>
-              <a:off x="8243888" y="3369945"/>
-              <a:ext cx="2278693" cy="176212"/>
-            </a:xfrm>
-            <a:prstGeom prst="rect">
-              <a:avLst/>
-            </a:prstGeom>
-            <a:noFill/>
-            <a:ln>
-              <a:noFill/>
-            </a:ln>
-          </p:spPr>
-          <p:txBody>
-            <a:bodyPr wrap="none" lIns="0" tIns="0" rIns="0" bIns="0" anchor="t" anchorCtr="0">
-              <a:spAutoFit/>
-            </a:bodyPr>
-            <a:lstStyle/>
-            <a:p>
-              <a:pPr algn="l"/>
-              <a:r>
-                <a:rPr lang="zh-CN" sz="900" dirty="0">
-                  <a:solidFill>
-                    <a:srgbClr val="626B73"/>
-                  </a:solidFill>
-                  <a:latin typeface="Arial"/>
-                  <a:ea typeface="Microsoft YaHei"/>
-                  <a:cs typeface="Arial"/>
-                </a:rPr>
-                <a:t>导出与加载传递 uniform_parameter_dtype</a:t>
+                <a:t>不再依赖 FlashAttention / Triton CUDA kernel</a:t>
               </a:r>
             </a:p>
           </p:txBody>
@@ -9930,7 +9930,7 @@
           <p:spPr>
             <a:xfrm>
               <a:off x="1212342" y="3854768"/>
-              <a:ext cx="1104138" cy="264033"/>
+              <a:ext cx="1285875" cy="264033"/>
             </a:xfrm>
             <a:prstGeom prst="rect">
               <a:avLst/>
@@ -9956,7 +9956,7 @@
                   <a:ea typeface="Microsoft YaHei"/>
                   <a:cs typeface="Arial"/>
                 </a:rPr>
-                <a:t>分布式与内存</a:t>
+                <a:t>权重加载与显存</a:t>
               </a:r>
             </a:p>
           </p:txBody>
@@ -10010,7 +10010,7 @@
           <p:spPr>
             <a:xfrm>
               <a:off x="3308985" y="3802856"/>
-              <a:ext cx="3588386" cy="220028"/>
+              <a:ext cx="2843749" cy="220028"/>
             </a:xfrm>
             <a:prstGeom prst="rect">
               <a:avLst/>
@@ -10036,7 +10036,7 @@
                   <a:ea typeface="Microsoft YaHei"/>
                   <a:cs typeface="Arial"/>
                 </a:rPr>
-                <a:t>Student、Teacher、Critic 启用 FSDP CPU offload</a:t>
+                <a:t>FSDP 分片前仍可能先装入完整 H3 权重</a:t>
               </a:r>
             </a:p>
           </p:txBody>
@@ -10050,7 +10050,7 @@
           <p:spPr>
             <a:xfrm>
               <a:off x="3309747" y="4066699"/>
-              <a:ext cx="3026178" cy="190690"/>
+              <a:ext cx="3081154" cy="190690"/>
             </a:xfrm>
             <a:prstGeom prst="rect">
               <a:avLst/>
@@ -10076,7 +10076,7 @@
                   <a:ea typeface="Microsoft YaHei"/>
                   <a:cs typeface="Arial"/>
                 </a:rPr>
-                <a:t>NPU 权重先在 CPU staging，再逐张量映射与分片</a:t>
+                <a:t>参数映射先构造完整 state dict，三角色放大装载峰值</a:t>
               </a:r>
             </a:p>
           </p:txBody>
@@ -10090,7 +10090,7 @@
           <p:spPr>
             <a:xfrm>
               <a:off x="3309938" y="4293870"/>
-              <a:ext cx="2757534" cy="176212"/>
+              <a:ext cx="1976113" cy="176212"/>
             </a:xfrm>
             <a:prstGeom prst="rect">
               <a:avLst/>
@@ -10116,7 +10116,7 @@
                   <a:ea typeface="Arial"/>
                   <a:cs typeface="Arial"/>
                 </a:rPr>
-                <a:t>fsdp_load.py · moduleloader.py · training_config.py</a:t>
+                <a:t>fsdp_load.py · models/loader/utils.py</a:t>
               </a:r>
             </a:p>
           </p:txBody>
@@ -10130,7 +10130,7 @@
           <p:spPr>
             <a:xfrm>
               <a:off x="8243316" y="3810952"/>
-              <a:ext cx="2159873" cy="205359"/>
+              <a:ext cx="3000281" cy="205359"/>
             </a:xfrm>
             <a:prstGeom prst="rect">
               <a:avLst/>
@@ -10156,7 +10156,7 @@
                   <a:ea typeface="Microsoft YaHei"/>
                   <a:cs typeface="Arial"/>
                 </a:rPr>
-                <a:t>避免完整 33B 权重同时进入单卡</a:t>
+                <a:t>NPU 强制 CPU staging，再逐张量映射与分片</a:t>
               </a:r>
             </a:p>
           </p:txBody>
@@ -10170,7 +10170,7 @@
           <p:spPr>
             <a:xfrm>
               <a:off x="8243697" y="4066699"/>
-              <a:ext cx="2120748" cy="190690"/>
+              <a:ext cx="3349130" cy="190690"/>
             </a:xfrm>
             <a:prstGeom prst="rect">
               <a:avLst/>
@@ -10196,7 +10196,7 @@
                   <a:ea typeface="Microsoft YaHei"/>
                   <a:cs typeface="Arial"/>
                 </a:rPr>
-                <a:t>延迟映射只保留未完成的合并参数组</a:t>
+                <a:t>三个角色开启 FSDP CPU offload；只保留未完成合并组</a:t>
               </a:r>
             </a:p>
           </p:txBody>
@@ -10210,7 +10210,7 @@
           <p:spPr>
             <a:xfrm>
               <a:off x="8243888" y="4293870"/>
-              <a:ext cx="2473856" cy="176212"/>
+              <a:ext cx="2553843" cy="176212"/>
             </a:xfrm>
             <a:prstGeom prst="rect">
               <a:avLst/>
@@ -10236,7 +10236,7 @@
                   <a:ea typeface="Microsoft YaHei"/>
                   <a:cs typeface="Arial"/>
                 </a:rPr>
-                <a:t>HCCL/SP warm-up 使用本地设备与平台同步</a:t>
+                <a:t>控制的是加载峰值和训练驻留显存两条生命周期</a:t>
               </a:r>
             </a:p>
           </p:txBody>
@@ -10349,7 +10349,7 @@
           <p:spPr>
             <a:xfrm>
               <a:off x="1212342" y="4854892"/>
-              <a:ext cx="1467612" cy="264033"/>
+              <a:ext cx="1285875" cy="264033"/>
             </a:xfrm>
             <a:prstGeom prst="rect">
               <a:avLst/>
@@ -10375,7 +10375,7 @@
                   <a:ea typeface="Microsoft YaHei"/>
                   <a:cs typeface="Arial"/>
                 </a:rPr>
-                <a:t>数据、训练与产物</a:t>
+                <a:t>启动与训练状态</a:t>
               </a:r>
             </a:p>
           </p:txBody>
@@ -10389,7 +10389,7 @@
           <p:spPr>
             <a:xfrm>
               <a:off x="1214438" y="5141595"/>
-              <a:ext cx="1930165" cy="176212"/>
+              <a:ext cx="1887136" cy="176212"/>
             </a:xfrm>
             <a:prstGeom prst="rect">
               <a:avLst/>
@@ -10415,7 +10415,7 @@
                   <a:ea typeface="Microsoft YaHei"/>
                   <a:cs typeface="Arial"/>
                 </a:rPr>
-                <a:t>从本地输入打通到独立四步 Student</a:t>
+                <a:t>把通用 NPU 骨架接入可运行入口</a:t>
               </a:r>
             </a:p>
           </p:txBody>
@@ -10429,7 +10429,7 @@
           <p:spPr>
             <a:xfrm>
               <a:off x="3308985" y="4726781"/>
-              <a:ext cx="3542987" cy="220028"/>
+              <a:ext cx="3948106" cy="220028"/>
             </a:xfrm>
             <a:prstGeom prst="rect">
               <a:avLst/>
@@ -10455,7 +10455,7 @@
                   <a:ea typeface="Microsoft YaHei"/>
                   <a:cs typeface="Arial"/>
                 </a:rPr>
-                <a:t>本地 H3 权重与任意有声 MP4，三组件顺序预处理</a:t>
+                <a:t>run.sh 只检测 nvidia-smi；checkpoint 保存 CUDA RNG</a:t>
               </a:r>
             </a:p>
           </p:txBody>
@@ -10469,7 +10469,7 @@
           <p:spPr>
             <a:xfrm>
               <a:off x="3309747" y="4990624"/>
-              <a:ext cx="3130937" cy="190690"/>
+              <a:ext cx="3557235" cy="190690"/>
             </a:xfrm>
             <a:prstGeom prst="rect">
               <a:avLst/>
@@ -10495,7 +10495,7 @@
                   <a:ea typeface="Microsoft YaHei"/>
                   <a:cs typeface="Arial"/>
                 </a:rPr>
-                <a:t>联合视频音频 DMD2；DCP 保存、恢复 NPU RNG</a:t>
+                <a:t>H3 训练缺少 910B 的设备可见性、HCCL 与显存配置入口</a:t>
               </a:r>
             </a:p>
           </p:txBody>
@@ -10509,7 +10509,7 @@
           <p:spPr>
             <a:xfrm>
               <a:off x="3309938" y="5217795"/>
-              <a:ext cx="4029959" cy="176212"/>
+              <a:ext cx="1713297" cy="176212"/>
             </a:xfrm>
             <a:prstGeom prst="rect">
               <a:avLst/>
@@ -10535,7 +10535,7 @@
                   <a:ea typeface="Arial"/>
                   <a:cs typeface="Arial"/>
                 </a:rPr>
-                <a:t>preprocess_minimax_h3_overfit.py · minimax_h3_dmd2.py · checkpoint.py</a:t>
+                <a:t>run.sh · train/utils/checkpoint.py</a:t>
               </a:r>
             </a:p>
           </p:txBody>
@@ -10549,7 +10549,7 @@
           <p:spPr>
             <a:xfrm>
               <a:off x="8243316" y="4734878"/>
-              <a:ext cx="1989582" cy="205359"/>
+              <a:ext cx="2504528" cy="205359"/>
             </a:xfrm>
             <a:prstGeom prst="rect">
               <a:avLst/>
@@ -10575,7 +10575,7 @@
                   <a:ea typeface="Microsoft YaHei"/>
                   <a:cs typeface="Arial"/>
                 </a:rPr>
-                <a:t>训练状态可以转成独立推理模型</a:t>
+                <a:t>新增 run_ascend.sh 与 910B 训练配置</a:t>
               </a:r>
             </a:p>
           </p:txBody>
@@ -10589,7 +10589,7 @@
           <p:spPr>
             <a:xfrm>
               <a:off x="8243697" y="4990624"/>
-              <a:ext cx="2401505" cy="190690"/>
+              <a:ext cx="3140047" cy="190690"/>
             </a:xfrm>
             <a:prstGeom prst="rect">
               <a:avLst/>
@@ -10615,7 +10615,7 @@
                   <a:ea typeface="Microsoft YaHei"/>
                   <a:cs typeface="Arial"/>
                 </a:rPr>
-                <a:t>DCP → Student 并持久化 dtype contract</a:t>
+                <a:t>torch_npu 检查、NPU 发现、HCCL 与显存分配设置</a:t>
               </a:r>
             </a:p>
           </p:txBody>
@@ -10629,7 +10629,7 @@
           <p:spPr>
             <a:xfrm>
               <a:off x="8243888" y="5217795"/>
-              <a:ext cx="2567301" cy="176212"/>
+              <a:ext cx="3247290" cy="176212"/>
             </a:xfrm>
             <a:prstGeom prst="rect">
               <a:avLst/>
@@ -10655,7 +10655,7 @@
                   <a:ea typeface="Microsoft YaHei"/>
                   <a:cs typeface="Arial"/>
                 </a:rPr>
-                <a:t>严格四次 forward；提供 Base / 四步同条件对比</a:t>
+                <a:t>checkpoint 按当前 accelerator 保存与恢复每个 rank 的 RNG</a:t>
               </a:r>
             </a:p>
           </p:txBody>
@@ -10669,33 +10669,33 @@
           <p:spPr>
             <a:xfrm>
               <a:off x="3309938" y="5435441"/>
-              <a:ext cx="5348416" cy="161925"/>
-            </a:xfrm>
-            <a:prstGeom prst="rect">
-              <a:avLst/>
-            </a:prstGeom>
-            <a:noFill/>
-            <a:ln>
-              <a:noFill/>
-            </a:ln>
-          </p:spPr>
-          <p:txBody>
-            <a:bodyPr wrap="none" lIns="0" tIns="0" rIns="0" bIns="0" anchor="t" anchorCtr="0">
-              <a:spAutoFit/>
-            </a:bodyPr>
-            <a:lstStyle/>
-            <a:p>
-              <a:pPr algn="l"/>
-              <a:r>
-                <a:rPr lang="en-US" sz="820" dirty="0">
+              <a:ext cx="4412485" cy="161925"/>
+            </a:xfrm>
+            <a:prstGeom prst="rect">
+              <a:avLst/>
+            </a:prstGeom>
+            <a:noFill/>
+            <a:ln>
+              <a:noFill/>
+            </a:ln>
+          </p:spPr>
+          <p:txBody>
+            <a:bodyPr wrap="none" lIns="0" tIns="0" rIns="0" bIns="0" anchor="t" anchorCtr="0">
+              <a:spAutoFit/>
+            </a:bodyPr>
+            <a:lstStyle/>
+            <a:p>
+              <a:pPr algn="l"/>
+              <a:r>
+                <a:rPr lang="zh-CN" sz="820" dirty="0">
                   <a:solidFill>
                     <a:srgbClr val="626B73"/>
                   </a:solidFill>
                   <a:latin typeface="Arial"/>
-                  <a:ea typeface="Arial"/>
+                  <a:ea typeface="Microsoft YaHei"/>
                   <a:cs typeface="Arial"/>
                 </a:rPr>
-                <a:t>dcp_to_diffusers.py · basic_minimax_h3_dense_4step_ascend.py · compare_minimax_h3_dense_ascend.py</a:t>
+                <a:t>结果：原版 FastVideo 的 NPU 基础能力真正覆盖 H3 Dense DMD2 训练与严格四步推理</a:t>
               </a:r>
             </a:p>
           </p:txBody>
@@ -10746,7 +10746,7 @@
           <p:spPr>
             <a:xfrm>
               <a:off x="726948" y="5891689"/>
-              <a:ext cx="7250125" cy="249364"/>
+              <a:ext cx="7911941" cy="249364"/>
             </a:xfrm>
             <a:prstGeom prst="rect">
               <a:avLst/>
@@ -10772,7 +10772,7 @@
                   <a:ea typeface="Microsoft YaHei"/>
                   <a:cs typeface="Arial"/>
                 </a:rPr>
-                <a:t>代码改动覆盖四条连续链路：设备调用、数值契约、权重生命周期，以及训练产物到推理入口。</a:t>
+                <a:t>核心工作：补齐设备调度、Attention、权重生命周期和 NPU 训练状态，而不是重写整个 FastVideo。</a:t>
               </a:r>
             </a:p>
           </p:txBody>
@@ -10786,7 +10786,7 @@
           <p:spPr>
             <a:xfrm>
               <a:off x="728662" y="6103620"/>
-              <a:ext cx="3401949" cy="176212"/>
+              <a:ext cx="5774805" cy="176212"/>
             </a:xfrm>
             <a:prstGeom prst="rect">
               <a:avLst/>
@@ -10812,7 +10812,7 @@
                   <a:ea typeface="Microsoft YaHei"/>
                   <a:cs typeface="Arial"/>
                 </a:rPr>
-                <a:t>每一层都对应当前补丁中的具体文件，不是抽象的迁移检查表。</a:t>
+                <a:t>上游已有 NPUPlatform 与 HCCL communicator；补丁解决的是 H3 路径仍无法在 910B 完整运行的问题。</a:t>
               </a:r>
             </a:p>
           </p:txBody>

</xml_diff>